<commit_message>
docs(pre2): update ai usage for slides
</commit_message>
<xml_diff>
--- a/assets/pre2/pre2_slides.pptx
+++ b/assets/pre2/pre2_slides.pptx
@@ -5164,7 +5164,7 @@
         <p:spPr>
           <a:xfrm>
             <a:off x="7715250" y="1714500"/>
-            <a:ext cx="0" cy="4000500"/>
+            <a:ext cx="635" cy="3475355"/>
           </a:xfrm>
           <a:prstGeom prst="line">
             <a:avLst/>
@@ -5186,7 +5186,7 @@
         </p:nvSpPr>
         <p:spPr>
           <a:xfrm>
-            <a:off x="504825" y="2047875"/>
+            <a:off x="504825" y="1649095"/>
             <a:ext cx="6715125" cy="3524250"/>
           </a:xfrm>
           <a:prstGeom prst="rect">
@@ -5364,7 +5364,7 @@
             </a:endParaRPr>
           </a:p>
           <a:p>
-            <a:pPr marL="254000" indent="-152400">
+            <a:pPr marL="711200" lvl="1" indent="-152400">
               <a:spcAft>
                 <a:spcPts val="1800"/>
               </a:spcAft>
@@ -5400,7 +5400,7 @@
             </a:endParaRPr>
           </a:p>
           <a:p>
-            <a:pPr marL="254000" indent="-152400">
+            <a:pPr marL="711200" lvl="1" indent="-152400">
               <a:spcAft>
                 <a:spcPts val="1800"/>
               </a:spcAft>
@@ -5436,7 +5436,7 @@
             </a:endParaRPr>
           </a:p>
           <a:p>
-            <a:pPr marL="254000" indent="-152400">
+            <a:pPr marL="711200" lvl="1" indent="-152400">
               <a:spcAft>
                 <a:spcPts val="1800"/>
               </a:spcAft>
@@ -5472,7 +5472,7 @@
             </a:endParaRPr>
           </a:p>
           <a:p>
-            <a:pPr marL="254000" indent="-152400">
+            <a:pPr marL="711200" lvl="1" indent="-152400">
               <a:spcAft>
                 <a:spcPts val="1800"/>
               </a:spcAft>
@@ -5508,7 +5508,7 @@
             </a:endParaRPr>
           </a:p>
           <a:p>
-            <a:pPr marL="254000" indent="-152400">
+            <a:pPr marL="711200" lvl="1" indent="-152400">
               <a:spcAft>
                 <a:spcPts val="1800"/>
               </a:spcAft>
@@ -5716,7 +5716,7 @@
         </p:nvSpPr>
         <p:spPr>
           <a:xfrm>
-            <a:off x="504825" y="6248400"/>
+            <a:off x="504825" y="5589270"/>
             <a:ext cx="11182350" cy="0"/>
           </a:xfrm>
           <a:prstGeom prst="line">
@@ -5739,7 +5739,7 @@
         </p:nvSpPr>
         <p:spPr>
           <a:xfrm>
-            <a:off x="504825" y="6362700"/>
+            <a:off x="504825" y="5661660"/>
             <a:ext cx="10477500" cy="266700"/>
           </a:xfrm>
           <a:prstGeom prst="rect">
@@ -5868,7 +5868,7 @@
               </a:defRPr>
             </a:pPr>
             <a:r>
-              <a:rPr sz="1200" b="0">
+              <a:rPr lang="en-US" altLang="zh-CN" sz="1200" b="0" u="sng">
                 <a:solidFill>
                   <a:srgbClr val="707070"/>
                 </a:solidFill>
@@ -5876,28 +5876,77 @@
                 <a:ea typeface="Arial" panose="020B0604020202090204"/>
                 <a:cs typeface="Arial" panose="020B0604020202090204"/>
               </a:rPr>
-              <a:t>Materials: </a:t>
+              <a:t>AI usage:</a:t>
             </a:r>
-            <a:r>
-              <a:rPr sz="1200" b="0" u="sng">
-                <a:solidFill>
-                  <a:srgbClr val="707070"/>
-                </a:solidFill>
-                <a:latin typeface="Arial" panose="020B0604020202090204"/>
-                <a:ea typeface="Arial" panose="020B0604020202090204"/>
-                <a:cs typeface="Arial" panose="020B0604020202090204"/>
-                <a:hlinkClick r:id="rId6"/>
-              </a:rPr>
-              <a:t>https://github.com/LionChenA/ads401/tree/main/assets/pre2/materials</a:t>
-            </a:r>
-            <a:endParaRPr sz="1200" b="0" u="sng">
+            <a:endParaRPr lang="en-US" altLang="zh-CN" sz="1200" b="0" u="sng">
               <a:solidFill>
                 <a:srgbClr val="707070"/>
               </a:solidFill>
               <a:latin typeface="Arial" panose="020B0604020202090204"/>
               <a:ea typeface="Arial" panose="020B0604020202090204"/>
               <a:cs typeface="Arial" panose="020B0604020202090204"/>
-              <a:hlinkClick r:id="rId6"/>
+            </a:endParaRPr>
+          </a:p>
+          <a:p>
+            <a:pPr>
+              <a:defRPr sz="1200" b="0">
+                <a:solidFill>
+                  <a:srgbClr val="707070"/>
+                </a:solidFill>
+                <a:latin typeface="Arial" panose="020B0604020202090204"/>
+                <a:ea typeface="Arial" panose="020B0604020202090204"/>
+                <a:cs typeface="Arial" panose="020B0604020202090204"/>
+              </a:defRPr>
+            </a:pPr>
+            <a:r>
+              <a:rPr lang="en-US" altLang="zh-CN" sz="1200" b="0" u="sng">
+                <a:solidFill>
+                  <a:srgbClr val="707070"/>
+                </a:solidFill>
+                <a:latin typeface="Arial" panose="020B0604020202090204"/>
+                <a:ea typeface="Arial" panose="020B0604020202090204"/>
+                <a:cs typeface="Arial" panose="020B0604020202090204"/>
+              </a:rPr>
+              <a:t>[1] GLM-5.3 Flash (Zhipu AI) and Gemini 3.8 Flash (Google), accessed via the omp agent harness. Used for slide layout and formatting, grammatical proofreading, and reference formatting.</a:t>
+            </a:r>
+            <a:endParaRPr lang="en-US" altLang="zh-CN" sz="1200" b="0" u="sng">
+              <a:solidFill>
+                <a:srgbClr val="707070"/>
+              </a:solidFill>
+              <a:latin typeface="Arial" panose="020B0604020202090204"/>
+              <a:ea typeface="Arial" panose="020B0604020202090204"/>
+              <a:cs typeface="Arial" panose="020B0604020202090204"/>
+            </a:endParaRPr>
+          </a:p>
+          <a:p>
+            <a:pPr>
+              <a:defRPr sz="1200" b="0">
+                <a:solidFill>
+                  <a:srgbClr val="707070"/>
+                </a:solidFill>
+                <a:latin typeface="Arial" panose="020B0604020202090204"/>
+                <a:ea typeface="Arial" panose="020B0604020202090204"/>
+                <a:cs typeface="Arial" panose="020B0604020202090204"/>
+              </a:defRPr>
+            </a:pPr>
+            <a:r>
+              <a:rPr lang="en-US" altLang="zh-CN" sz="1200" b="0" u="sng">
+                <a:solidFill>
+                  <a:srgbClr val="707070"/>
+                </a:solidFill>
+                <a:latin typeface="Arial" panose="020B0604020202090204"/>
+                <a:ea typeface="Arial" panose="020B0604020202090204"/>
+                <a:cs typeface="Arial" panose="020B0604020202090204"/>
+              </a:rPr>
+              <a:t>[2] ChatGPT 6 Astra (OpenAI), available at https://chatgpt.com. Used to organise research materials, locate relevant literature, and generate and revise slides based on the supplied research script.</a:t>
+            </a:r>
+            <a:endParaRPr lang="en-US" altLang="zh-CN" sz="1200" b="0" u="sng">
+              <a:solidFill>
+                <a:srgbClr val="707070"/>
+              </a:solidFill>
+              <a:latin typeface="Arial" panose="020B0604020202090204"/>
+              <a:ea typeface="Arial" panose="020B0604020202090204"/>
+              <a:cs typeface="Arial" panose="020B0604020202090204"/>
             </a:endParaRPr>
           </a:p>
         </p:txBody>

</xml_diff>